<commit_message>
fix: correct 4 bugs found in code and presentation
- requirements.txt: fix chromadb version 0.6.3 -> 1.5.9 (matches
  installed venv and slide 9 of presentation)

- backend/main.py lifespan: fix startup log double-count
  (was: count + collection.count(), which added new chunks twice;
   now: collection.count() = actual total in DB)

- backend/main.py lifespan: fix Mode log message to reflect actual
  runtime state (reads llm_client.demo_mode after _init_watsonx()
  runs, instead of the pre-init DEMO_MODE flag from config.py)

- DIP_Diet_RAG_Agent_Presentation.pptx slide 15: fix weight-loss
  calorie deficit from -500 kcal to -400 kcal to match
  meal_plan_generator.py line 52 (calories = tdee - 400),
  and correct the sample output from 1,450 kcal to 1,550 kcal
</commit_message>
<xml_diff>
--- a/dip_diet_agent/DIP_Diet_RAG_Agent_Presentation.pptx
+++ b/dip_diet_agent/DIP_Diet_RAG_Agent_Presentation.pptx
@@ -1,6 +1,6 @@
 
 <file path=ppt/presentation.xml><?xml version="1.0" encoding="utf-8"?>
-<p:presentation xmlns:a="http://schemas.openxmlformats.org/drawingml/2006/main" xmlns:r="http://schemas.openxmlformats.org/officeDocument/2006/relationships" xmlns:p="http://schemas.openxmlformats.org/presentationml/2006/main">
+<p:presentation xmlns:p15="http://schemas.microsoft.com/office/powerpoint/2012/main" xmlns:a="http://schemas.openxmlformats.org/drawingml/2006/main" xmlns:r="http://schemas.openxmlformats.org/officeDocument/2006/relationships" xmlns:p="http://schemas.openxmlformats.org/presentationml/2006/main">
   <p:sldMasterIdLst>
     <p:sldMasterId id="2147483648" r:id="rId1"/>
   </p:sldMasterIdLst>
@@ -131,6 +131,11 @@
       </a:defRPr>
     </a:lvl9pPr>
   </p:defaultTextStyle>
+  <p:extLst>
+    <p:ext uri="{EFAFB233-063F-42B5-8137-9DF3F51BA10A}">
+      <p15:sldGuideLst xmlns:p15="http://schemas.microsoft.com/office/powerpoint/2012/main"/>
+    </p:ext>
+  </p:extLst>
 </p:presentation>
 </file>
 
@@ -216,7 +221,7 @@
           <a:p>
             <a:fld id="{B1E4B0A2-5C8E-4E5F-9C1D-2F3A4B5C6D71}" type="datetimeFigureOut">
               <a:rPr lang="en-US"/>
-              <a:t>10/14/2026</a:t>
+              <a:t>10/15/2026</a:t>
             </a:fld>
             <a:endParaRPr lang="en-US"/>
           </a:p>
@@ -5752,7 +5757,7 @@
                 <a:latin typeface="Calibri"/>
                 <a:ea typeface="Calibri"/>
               </a:rPr>
-              <a:t>    Weight loss:  -500 kcal deficit</a:t>
+              <a:t>    Weight loss:  -400 kcal deficit</a:t>
             </a:r>
           </a:p>
           <a:p>
@@ -5904,7 +5909,7 @@
                 <a:latin typeface="Courier New"/>
                 <a:ea typeface="Courier New"/>
               </a:rPr>
-              <a:t>Target Cal:  1,450 kcal  (-500)</a:t>
+              <a:t>Target Cal:  1,550 kcal  (-400)</a:t>
             </a:r>
           </a:p>
           <a:p>

</xml_diff>